<commit_message>
Microservicios & Domain Design DDD
</commit_message>
<xml_diff>
--- a/Slides/7_SOA_metdologia_cf.pptx
+++ b/Slides/7_SOA_metdologia_cf.pptx
@@ -25,6 +25,8 @@
     <p:sldId id="271" r:id="rId19"/>
     <p:sldId id="272" r:id="rId20"/>
     <p:sldId id="273" r:id="rId21"/>
+    <p:sldId id="285" r:id="rId22"/>
+    <p:sldId id="286" r:id="rId23"/>
   </p:sldIdLst>
   <p:sldSz cx="12192000" cy="6858000"/>
   <p:notesSz cx="6858000" cy="9144000"/>
@@ -136,7 +138,7 @@
   <pc:docChgLst>
     <pc:chgData name="Cesar Augusto Lopez Gallego" userId="0dfa9112-9251-4882-b472-cf2dfcee09d1" providerId="ADAL" clId="{76F12681-65F0-4192-B274-D40FC8B71DD1}"/>
     <pc:docChg chg="undo custSel addSld delSld modSld sldOrd">
-      <pc:chgData name="Cesar Augusto Lopez Gallego" userId="0dfa9112-9251-4882-b472-cf2dfcee09d1" providerId="ADAL" clId="{76F12681-65F0-4192-B274-D40FC8B71DD1}" dt="2026-03-17T12:05:06.837" v="3768"/>
+      <pc:chgData name="Cesar Augusto Lopez Gallego" userId="0dfa9112-9251-4882-b472-cf2dfcee09d1" providerId="ADAL" clId="{76F12681-65F0-4192-B274-D40FC8B71DD1}" dt="2026-04-07T12:16:12.451" v="4429" actId="6549"/>
       <pc:docMkLst>
         <pc:docMk/>
       </pc:docMkLst>
@@ -1058,7 +1060,7 @@
         </pc:picChg>
       </pc:sldChg>
       <pc:sldChg chg="addSp delSp modSp new mod setBg">
-        <pc:chgData name="Cesar Augusto Lopez Gallego" userId="0dfa9112-9251-4882-b472-cf2dfcee09d1" providerId="ADAL" clId="{76F12681-65F0-4192-B274-D40FC8B71DD1}" dt="2026-03-17T12:05:02.477" v="3767" actId="14100"/>
+        <pc:chgData name="Cesar Augusto Lopez Gallego" userId="0dfa9112-9251-4882-b472-cf2dfcee09d1" providerId="ADAL" clId="{76F12681-65F0-4192-B274-D40FC8B71DD1}" dt="2026-04-07T12:16:12.451" v="4429" actId="6549"/>
         <pc:sldMkLst>
           <pc:docMk/>
           <pc:sldMk cId="3933606175" sldId="273"/>
@@ -1072,7 +1074,7 @@
           </ac:spMkLst>
         </pc:spChg>
         <pc:spChg chg="add mod">
-          <ac:chgData name="Cesar Augusto Lopez Gallego" userId="0dfa9112-9251-4882-b472-cf2dfcee09d1" providerId="ADAL" clId="{76F12681-65F0-4192-B274-D40FC8B71DD1}" dt="2026-03-17T10:26:20.087" v="3363" actId="20577"/>
+          <ac:chgData name="Cesar Augusto Lopez Gallego" userId="0dfa9112-9251-4882-b472-cf2dfcee09d1" providerId="ADAL" clId="{76F12681-65F0-4192-B274-D40FC8B71DD1}" dt="2026-04-07T12:16:12.451" v="4429" actId="6549"/>
           <ac:spMkLst>
             <pc:docMk/>
             <pc:sldMk cId="3933606175" sldId="273"/>
@@ -1274,6 +1276,100 @@
             <ac:picMk id="8" creationId="{E3FEF293-7BBC-4E2F-9538-FB5557152772}"/>
           </ac:picMkLst>
         </pc:picChg>
+      </pc:sldChg>
+      <pc:sldChg chg="addSp delSp modSp new mod">
+        <pc:chgData name="Cesar Augusto Lopez Gallego" userId="0dfa9112-9251-4882-b472-cf2dfcee09d1" providerId="ADAL" clId="{76F12681-65F0-4192-B274-D40FC8B71DD1}" dt="2026-03-25T12:27:15.607" v="4418" actId="113"/>
+        <pc:sldMkLst>
+          <pc:docMk/>
+          <pc:sldMk cId="1884975599" sldId="285"/>
+        </pc:sldMkLst>
+        <pc:spChg chg="del">
+          <ac:chgData name="Cesar Augusto Lopez Gallego" userId="0dfa9112-9251-4882-b472-cf2dfcee09d1" providerId="ADAL" clId="{76F12681-65F0-4192-B274-D40FC8B71DD1}" dt="2026-03-25T11:51:10.793" v="3770" actId="478"/>
+          <ac:spMkLst>
+            <pc:docMk/>
+            <pc:sldMk cId="1884975599" sldId="285"/>
+            <ac:spMk id="2" creationId="{D0956854-E4DD-4711-96C3-302DC43CB93C}"/>
+          </ac:spMkLst>
+        </pc:spChg>
+        <pc:spChg chg="del">
+          <ac:chgData name="Cesar Augusto Lopez Gallego" userId="0dfa9112-9251-4882-b472-cf2dfcee09d1" providerId="ADAL" clId="{76F12681-65F0-4192-B274-D40FC8B71DD1}" dt="2026-03-25T11:51:10.793" v="3770" actId="478"/>
+          <ac:spMkLst>
+            <pc:docMk/>
+            <pc:sldMk cId="1884975599" sldId="285"/>
+            <ac:spMk id="3" creationId="{88601745-79DF-453E-A1B9-2FAA4916F6D6}"/>
+          </ac:spMkLst>
+        </pc:spChg>
+        <pc:spChg chg="add mod">
+          <ac:chgData name="Cesar Augusto Lopez Gallego" userId="0dfa9112-9251-4882-b472-cf2dfcee09d1" providerId="ADAL" clId="{76F12681-65F0-4192-B274-D40FC8B71DD1}" dt="2026-03-25T12:24:52.720" v="4380" actId="14100"/>
+          <ac:spMkLst>
+            <pc:docMk/>
+            <pc:sldMk cId="1884975599" sldId="285"/>
+            <ac:spMk id="4" creationId="{BE06151D-79AC-4C3F-A38E-E48F009E6385}"/>
+          </ac:spMkLst>
+        </pc:spChg>
+        <pc:spChg chg="add mod">
+          <ac:chgData name="Cesar Augusto Lopez Gallego" userId="0dfa9112-9251-4882-b472-cf2dfcee09d1" providerId="ADAL" clId="{76F12681-65F0-4192-B274-D40FC8B71DD1}" dt="2026-03-25T12:27:15.607" v="4418" actId="113"/>
+          <ac:spMkLst>
+            <pc:docMk/>
+            <pc:sldMk cId="1884975599" sldId="285"/>
+            <ac:spMk id="5" creationId="{55B83617-4A11-40FB-9818-7E5EC3553D48}"/>
+          </ac:spMkLst>
+        </pc:spChg>
+        <pc:spChg chg="add del">
+          <ac:chgData name="Cesar Augusto Lopez Gallego" userId="0dfa9112-9251-4882-b472-cf2dfcee09d1" providerId="ADAL" clId="{76F12681-65F0-4192-B274-D40FC8B71DD1}" dt="2026-03-25T12:22:59.968" v="4334"/>
+          <ac:spMkLst>
+            <pc:docMk/>
+            <pc:sldMk cId="1884975599" sldId="285"/>
+            <ac:spMk id="6" creationId="{A727C58E-BC2F-4ACB-B02C-CF24FABC9AF9}"/>
+          </ac:spMkLst>
+        </pc:spChg>
+        <pc:spChg chg="add del">
+          <ac:chgData name="Cesar Augusto Lopez Gallego" userId="0dfa9112-9251-4882-b472-cf2dfcee09d1" providerId="ADAL" clId="{76F12681-65F0-4192-B274-D40FC8B71DD1}" dt="2026-03-25T12:23:04.837" v="4336"/>
+          <ac:spMkLst>
+            <pc:docMk/>
+            <pc:sldMk cId="1884975599" sldId="285"/>
+            <ac:spMk id="7" creationId="{511F9A1B-B3B7-4C37-97A3-8F8A6712919B}"/>
+          </ac:spMkLst>
+        </pc:spChg>
+      </pc:sldChg>
+      <pc:sldChg chg="addSp delSp modSp new mod">
+        <pc:chgData name="Cesar Augusto Lopez Gallego" userId="0dfa9112-9251-4882-b472-cf2dfcee09d1" providerId="ADAL" clId="{76F12681-65F0-4192-B274-D40FC8B71DD1}" dt="2026-03-25T12:26:18.447" v="4403" actId="6549"/>
+        <pc:sldMkLst>
+          <pc:docMk/>
+          <pc:sldMk cId="3608644513" sldId="286"/>
+        </pc:sldMkLst>
+        <pc:spChg chg="del">
+          <ac:chgData name="Cesar Augusto Lopez Gallego" userId="0dfa9112-9251-4882-b472-cf2dfcee09d1" providerId="ADAL" clId="{76F12681-65F0-4192-B274-D40FC8B71DD1}" dt="2026-03-25T12:24:31.032" v="4374" actId="478"/>
+          <ac:spMkLst>
+            <pc:docMk/>
+            <pc:sldMk cId="3608644513" sldId="286"/>
+            <ac:spMk id="2" creationId="{88051A86-523D-4563-93B8-388376673911}"/>
+          </ac:spMkLst>
+        </pc:spChg>
+        <pc:spChg chg="del">
+          <ac:chgData name="Cesar Augusto Lopez Gallego" userId="0dfa9112-9251-4882-b472-cf2dfcee09d1" providerId="ADAL" clId="{76F12681-65F0-4192-B274-D40FC8B71DD1}" dt="2026-03-25T12:24:31.032" v="4374" actId="478"/>
+          <ac:spMkLst>
+            <pc:docMk/>
+            <pc:sldMk cId="3608644513" sldId="286"/>
+            <ac:spMk id="3" creationId="{00BCCE1B-1A7D-4139-9916-6DA37A6DA4DE}"/>
+          </ac:spMkLst>
+        </pc:spChg>
+        <pc:spChg chg="add mod">
+          <ac:chgData name="Cesar Augusto Lopez Gallego" userId="0dfa9112-9251-4882-b472-cf2dfcee09d1" providerId="ADAL" clId="{76F12681-65F0-4192-B274-D40FC8B71DD1}" dt="2026-03-25T12:26:18.447" v="4403" actId="6549"/>
+          <ac:spMkLst>
+            <pc:docMk/>
+            <pc:sldMk cId="3608644513" sldId="286"/>
+            <ac:spMk id="5" creationId="{2BC420AA-DF87-4331-AEB4-3E145A370204}"/>
+          </ac:spMkLst>
+        </pc:spChg>
+        <pc:spChg chg="add mod">
+          <ac:chgData name="Cesar Augusto Lopez Gallego" userId="0dfa9112-9251-4882-b472-cf2dfcee09d1" providerId="ADAL" clId="{76F12681-65F0-4192-B274-D40FC8B71DD1}" dt="2026-03-25T12:25:12.901" v="4383"/>
+          <ac:spMkLst>
+            <pc:docMk/>
+            <pc:sldMk cId="3608644513" sldId="286"/>
+            <ac:spMk id="6" creationId="{0F220360-C56E-4C21-B577-8DAB35A1BF10}"/>
+          </ac:spMkLst>
+        </pc:spChg>
       </pc:sldChg>
       <pc:sldMasterChg chg="addSldLayout">
         <pc:chgData name="Cesar Augusto Lopez Gallego" userId="0dfa9112-9251-4882-b472-cf2dfcee09d1" providerId="ADAL" clId="{76F12681-65F0-4192-B274-D40FC8B71DD1}" dt="2026-03-07T14:46:51.752" v="0" actId="680"/>
@@ -2563,7 +2659,7 @@
           <a:p>
             <a:fld id="{6B86245D-015E-46AE-96CC-32E8A5E9A1DF}" type="datetimeFigureOut">
               <a:rPr lang="es-CO" smtClean="0"/>
-              <a:t>17/03/2026</a:t>
+              <a:t>7/04/2026</a:t>
             </a:fld>
             <a:endParaRPr lang="es-CO"/>
           </a:p>
@@ -2733,7 +2829,7 @@
           <a:p>
             <a:fld id="{6B86245D-015E-46AE-96CC-32E8A5E9A1DF}" type="datetimeFigureOut">
               <a:rPr lang="es-CO" smtClean="0"/>
-              <a:t>17/03/2026</a:t>
+              <a:t>7/04/2026</a:t>
             </a:fld>
             <a:endParaRPr lang="es-CO"/>
           </a:p>
@@ -2965,7 +3061,7 @@
           <a:p>
             <a:fld id="{6B86245D-015E-46AE-96CC-32E8A5E9A1DF}" type="datetimeFigureOut">
               <a:rPr lang="es-CO" smtClean="0"/>
-              <a:t>17/03/2026</a:t>
+              <a:t>7/04/2026</a:t>
             </a:fld>
             <a:endParaRPr lang="es-CO"/>
           </a:p>
@@ -3157,7 +3253,7 @@
           <a:p>
             <a:fld id="{6B86245D-015E-46AE-96CC-32E8A5E9A1DF}" type="datetimeFigureOut">
               <a:rPr lang="es-CO" smtClean="0"/>
-              <a:t>17/03/2026</a:t>
+              <a:t>7/04/2026</a:t>
             </a:fld>
             <a:endParaRPr lang="es-CO"/>
           </a:p>
@@ -7630,7 +7726,7 @@
           <a:p>
             <a:r>
               <a:rPr lang="es-ES" sz="3600" dirty="0"/>
-              <a:t>PRIMER TRABAJO ARQUITECTURAS EMPRESARIALES – 3er 25%</a:t>
+              <a:t>PRIMER TRABAJO ARQUITECTURAS SOFTWARE EMPRESARIAL – 3er 25%</a:t>
             </a:r>
           </a:p>
         </p:txBody>
@@ -7752,6 +7848,756 @@
   </p:cSld>
   <p:clrMapOvr>
     <a:overrideClrMapping bg1="lt1" tx1="dk1" bg2="lt2" tx2="dk2" accent1="accent1" accent2="accent2" accent3="accent3" accent4="accent4" accent5="accent5" accent6="accent6" hlink="hlink" folHlink="folHlink"/>
+  </p:clrMapOvr>
+</p:sld>
+</file>
+
+<file path=ppt/slides/slide21.xml><?xml version="1.0" encoding="utf-8"?>
+<p:sld xmlns:a="http://schemas.openxmlformats.org/drawingml/2006/main" xmlns:r="http://schemas.openxmlformats.org/officeDocument/2006/relationships" xmlns:p="http://schemas.openxmlformats.org/presentationml/2006/main">
+  <p:cSld>
+    <p:spTree>
+      <p:nvGrpSpPr>
+        <p:cNvPr id="1" name=""/>
+        <p:cNvGrpSpPr/>
+        <p:nvPr/>
+      </p:nvGrpSpPr>
+      <p:grpSpPr>
+        <a:xfrm>
+          <a:off x="0" y="0"/>
+          <a:ext cx="0" cy="0"/>
+          <a:chOff x="0" y="0"/>
+          <a:chExt cx="0" cy="0"/>
+        </a:xfrm>
+      </p:grpSpPr>
+      <p:sp>
+        <p:nvSpPr>
+          <p:cNvPr id="4" name="CuadroTexto 3">
+            <a:extLst>
+              <a:ext uri="{FF2B5EF4-FFF2-40B4-BE49-F238E27FC236}">
+                <a16:creationId xmlns:a16="http://schemas.microsoft.com/office/drawing/2014/main" id="{BE06151D-79AC-4C3F-A38E-E48F009E6385}"/>
+              </a:ext>
+            </a:extLst>
+          </p:cNvPr>
+          <p:cNvSpPr txBox="1"/>
+          <p:nvPr/>
+        </p:nvSpPr>
+        <p:spPr>
+          <a:xfrm flipH="1">
+            <a:off x="755066" y="447156"/>
+            <a:ext cx="6383863" cy="646331"/>
+          </a:xfrm>
+          <a:prstGeom prst="rect">
+            <a:avLst/>
+          </a:prstGeom>
+          <a:noFill/>
+        </p:spPr>
+        <p:txBody>
+          <a:bodyPr wrap="square" rtlCol="0">
+            <a:spAutoFit/>
+          </a:bodyPr>
+          <a:lstStyle/>
+          <a:p>
+            <a:r>
+              <a:rPr lang="es-ES" sz="3600" dirty="0"/>
+              <a:t>Glosario proyectos</a:t>
+            </a:r>
+          </a:p>
+        </p:txBody>
+      </p:sp>
+      <p:sp>
+        <p:nvSpPr>
+          <p:cNvPr id="5" name="CuadroTexto 4">
+            <a:extLst>
+              <a:ext uri="{FF2B5EF4-FFF2-40B4-BE49-F238E27FC236}">
+                <a16:creationId xmlns:a16="http://schemas.microsoft.com/office/drawing/2014/main" id="{55B83617-4A11-40FB-9818-7E5EC3553D48}"/>
+              </a:ext>
+            </a:extLst>
+          </p:cNvPr>
+          <p:cNvSpPr txBox="1"/>
+          <p:nvPr/>
+        </p:nvSpPr>
+        <p:spPr>
+          <a:xfrm>
+            <a:off x="595734" y="1302808"/>
+            <a:ext cx="10696555" cy="4524315"/>
+          </a:xfrm>
+          <a:prstGeom prst="rect">
+            <a:avLst/>
+          </a:prstGeom>
+          <a:noFill/>
+        </p:spPr>
+        <p:txBody>
+          <a:bodyPr wrap="square">
+            <a:spAutoFit/>
+          </a:bodyPr>
+          <a:lstStyle/>
+          <a:p>
+            <a:r>
+              <a:rPr lang="es-ES" sz="1600" b="1" dirty="0">
+                <a:highlight>
+                  <a:srgbClr val="FFFF00"/>
+                </a:highlight>
+              </a:rPr>
+              <a:t>Cliente</a:t>
+            </a:r>
+          </a:p>
+          <a:p>
+            <a:endParaRPr lang="es-ES" sz="1600" dirty="0"/>
+          </a:p>
+          <a:p>
+            <a:r>
+              <a:rPr lang="es-ES" sz="1600" b="1" dirty="0" err="1"/>
+              <a:t>Await</a:t>
+            </a:r>
+            <a:r>
+              <a:rPr lang="es-ES" sz="1600" dirty="0"/>
+              <a:t> instrucción que ordena esperar</a:t>
+            </a:r>
+            <a:r>
+              <a:rPr lang="es-ES" sz="1600" b="0" i="0" dirty="0">
+                <a:solidFill>
+                  <a:srgbClr val="0A0A0A"/>
+                </a:solidFill>
+                <a:effectLst/>
+                <a:latin typeface="Google Sans"/>
+              </a:rPr>
+              <a:t> a que una tarea termine sin bloquear todo el sistema</a:t>
+            </a:r>
+            <a:endParaRPr lang="es-ES" sz="1600" dirty="0"/>
+          </a:p>
+          <a:p>
+            <a:r>
+              <a:rPr lang="es-ES" sz="1600" b="1" dirty="0" err="1"/>
+              <a:t>GetAsync</a:t>
+            </a:r>
+            <a:r>
+              <a:rPr lang="es-ES" sz="1600" dirty="0"/>
+              <a:t> </a:t>
+            </a:r>
+            <a:r>
+              <a:rPr lang="es-ES" sz="1600" b="0" i="0" dirty="0">
+                <a:solidFill>
+                  <a:srgbClr val="0A0A0A"/>
+                </a:solidFill>
+                <a:effectLst/>
+                <a:latin typeface="Google Sans"/>
+              </a:rPr>
+              <a:t>Se usa para pedir información a un servidor (</a:t>
+            </a:r>
+            <a:r>
+              <a:rPr lang="es-ES" sz="1600" b="1" i="0" dirty="0">
+                <a:solidFill>
+                  <a:srgbClr val="0A0A0A"/>
+                </a:solidFill>
+                <a:effectLst/>
+                <a:latin typeface="Google Sans"/>
+              </a:rPr>
+              <a:t>GET</a:t>
+            </a:r>
+            <a:r>
+              <a:rPr lang="es-ES" sz="1600" b="0" i="0" dirty="0">
+                <a:solidFill>
+                  <a:srgbClr val="0A0A0A"/>
+                </a:solidFill>
+                <a:effectLst/>
+                <a:latin typeface="Google Sans"/>
+              </a:rPr>
+              <a:t>). Es "</a:t>
+            </a:r>
+            <a:r>
+              <a:rPr lang="es-ES" sz="1600" b="0" i="0" dirty="0" err="1">
+                <a:solidFill>
+                  <a:srgbClr val="0A0A0A"/>
+                </a:solidFill>
+                <a:effectLst/>
+                <a:latin typeface="Google Sans"/>
+              </a:rPr>
+              <a:t>Async</a:t>
+            </a:r>
+            <a:r>
+              <a:rPr lang="es-ES" sz="1600" b="0" i="0" dirty="0">
+                <a:solidFill>
+                  <a:srgbClr val="0A0A0A"/>
+                </a:solidFill>
+                <a:effectLst/>
+                <a:latin typeface="Google Sans"/>
+              </a:rPr>
+              <a:t>" para no detener el programa mientras el servidor responde.</a:t>
+            </a:r>
+            <a:endParaRPr lang="es-ES" sz="1600" dirty="0"/>
+          </a:p>
+          <a:p>
+            <a:r>
+              <a:rPr lang="es-ES" sz="1600" b="1" dirty="0" err="1"/>
+              <a:t>PostAsync</a:t>
+            </a:r>
+            <a:r>
+              <a:rPr lang="es-ES" sz="1600" dirty="0"/>
+              <a:t> </a:t>
+            </a:r>
+            <a:r>
+              <a:rPr lang="es-ES" sz="1600" b="0" i="0" dirty="0">
+                <a:solidFill>
+                  <a:srgbClr val="0A0A0A"/>
+                </a:solidFill>
+                <a:effectLst/>
+                <a:latin typeface="Google Sans"/>
+              </a:rPr>
+              <a:t>Se usa para enviar datos nuevos a un servidor (</a:t>
+            </a:r>
+            <a:r>
+              <a:rPr lang="es-ES" sz="1600" b="1" i="0" dirty="0">
+                <a:solidFill>
+                  <a:srgbClr val="0A0A0A"/>
+                </a:solidFill>
+                <a:effectLst/>
+                <a:latin typeface="Google Sans"/>
+              </a:rPr>
+              <a:t>POST</a:t>
+            </a:r>
+            <a:r>
+              <a:rPr lang="es-ES" sz="1600" b="0" i="0" dirty="0">
+                <a:solidFill>
+                  <a:srgbClr val="0A0A0A"/>
+                </a:solidFill>
+                <a:effectLst/>
+                <a:latin typeface="Google Sans"/>
+              </a:rPr>
+              <a:t>)</a:t>
+            </a:r>
+            <a:endParaRPr lang="es-ES" sz="1600" dirty="0"/>
+          </a:p>
+          <a:p>
+            <a:r>
+              <a:rPr lang="es-ES" sz="1600" b="1" dirty="0" err="1"/>
+              <a:t>JsonSerializer</a:t>
+            </a:r>
+            <a:r>
+              <a:rPr lang="es-ES" sz="1600" b="1" dirty="0"/>
+              <a:t> – </a:t>
+            </a:r>
+            <a:r>
+              <a:rPr lang="es-ES" sz="1600" b="1" dirty="0" err="1"/>
+              <a:t>Deserializer</a:t>
+            </a:r>
+            <a:r>
+              <a:rPr lang="es-ES" sz="1600" dirty="0"/>
+              <a:t>  Conversiones entre objetos C# a clase ) a un texto en formato JSON y </a:t>
+            </a:r>
+            <a:r>
+              <a:rPr lang="es-ES" sz="1600" dirty="0" err="1"/>
+              <a:t>visceversa</a:t>
+            </a:r>
+            <a:endParaRPr lang="es-ES" sz="1600" dirty="0"/>
+          </a:p>
+          <a:p>
+            <a:endParaRPr lang="es-ES" sz="1600" dirty="0"/>
+          </a:p>
+          <a:p>
+            <a:r>
+              <a:rPr lang="es-ES" sz="1600" b="1" dirty="0">
+                <a:highlight>
+                  <a:srgbClr val="FFFF00"/>
+                </a:highlight>
+              </a:rPr>
+              <a:t>ESB</a:t>
+            </a:r>
+          </a:p>
+          <a:p>
+            <a:endParaRPr lang="es-ES" sz="1600" dirty="0"/>
+          </a:p>
+          <a:p>
+            <a:r>
+              <a:rPr lang="es-ES" sz="1600" b="1" dirty="0" err="1"/>
+              <a:t>Ilogger</a:t>
+            </a:r>
+            <a:r>
+              <a:rPr lang="es-ES" sz="1600" dirty="0"/>
+              <a:t> </a:t>
+            </a:r>
+            <a:r>
+              <a:rPr lang="es-ES" sz="1600" b="0" i="0" dirty="0">
+                <a:solidFill>
+                  <a:srgbClr val="0A0A0A"/>
+                </a:solidFill>
+                <a:effectLst/>
+                <a:latin typeface="Google Sans"/>
+              </a:rPr>
+              <a:t>Es la herramienta para escribir mensajes de diagnóstico (errores, advertencias o </a:t>
+            </a:r>
+            <a:r>
+              <a:rPr lang="es-ES" sz="1600" b="0" i="0" dirty="0" err="1">
+                <a:solidFill>
+                  <a:srgbClr val="0A0A0A"/>
+                </a:solidFill>
+                <a:effectLst/>
+                <a:latin typeface="Google Sans"/>
+              </a:rPr>
+              <a:t>info</a:t>
+            </a:r>
+            <a:r>
+              <a:rPr lang="es-ES" sz="1600" b="0" i="0" dirty="0">
+                <a:solidFill>
+                  <a:srgbClr val="0A0A0A"/>
+                </a:solidFill>
+                <a:effectLst/>
+                <a:latin typeface="Google Sans"/>
+              </a:rPr>
+              <a:t>) en la consola o en archivos</a:t>
+            </a:r>
+            <a:endParaRPr lang="es-ES" sz="1600" dirty="0"/>
+          </a:p>
+          <a:p>
+            <a:r>
+              <a:rPr lang="es-ES" sz="1600" b="1" dirty="0" err="1"/>
+              <a:t>IRoutingService</a:t>
+            </a:r>
+            <a:r>
+              <a:rPr lang="es-ES" sz="1600" dirty="0"/>
+              <a:t> </a:t>
+            </a:r>
+            <a:r>
+              <a:rPr lang="es-ES" sz="1600" b="0" i="0" dirty="0">
+                <a:solidFill>
+                  <a:srgbClr val="0A0A0A"/>
+                </a:solidFill>
+                <a:effectLst/>
+                <a:latin typeface="Google Sans"/>
+              </a:rPr>
+              <a:t>interfaz que se encarga de decidir a dónde debe ir una petición dentro de la aplicación.</a:t>
+            </a:r>
+            <a:endParaRPr lang="es-ES" sz="1600" dirty="0"/>
+          </a:p>
+          <a:p>
+            <a:r>
+              <a:rPr lang="es-ES" sz="1600" b="1" dirty="0" err="1"/>
+              <a:t>RouteRequestAsync</a:t>
+            </a:r>
+            <a:r>
+              <a:rPr lang="es-ES" sz="1600" dirty="0"/>
+              <a:t>, </a:t>
+            </a:r>
+            <a:r>
+              <a:rPr lang="es-ES" sz="1600" b="0" i="0" dirty="0">
+                <a:solidFill>
+                  <a:srgbClr val="0A0A0A"/>
+                </a:solidFill>
+                <a:effectLst/>
+                <a:latin typeface="Google Sans"/>
+              </a:rPr>
+              <a:t>método que busca el destino de una petición y la prepara para ser enviada.</a:t>
+            </a:r>
+            <a:endParaRPr lang="es-ES" sz="1600" dirty="0"/>
+          </a:p>
+          <a:p>
+            <a:r>
+              <a:rPr lang="es-ES" sz="1600" b="1" dirty="0" err="1"/>
+              <a:t>RouteAndTransformAsync</a:t>
+            </a:r>
+            <a:r>
+              <a:rPr lang="es-ES" sz="1600" dirty="0"/>
+              <a:t> parecido al anterior </a:t>
+            </a:r>
+            <a:r>
+              <a:rPr lang="es-ES" sz="1600" b="0" i="0" dirty="0">
+                <a:solidFill>
+                  <a:srgbClr val="0A0A0A"/>
+                </a:solidFill>
+                <a:effectLst/>
+                <a:latin typeface="Google Sans"/>
+              </a:rPr>
+              <a:t>pero además de redirigir la petición, </a:t>
+            </a:r>
+            <a:r>
+              <a:rPr lang="es-ES" sz="1600" b="1" i="0" dirty="0">
+                <a:solidFill>
+                  <a:srgbClr val="0A0A0A"/>
+                </a:solidFill>
+                <a:effectLst/>
+                <a:latin typeface="Google Sans"/>
+              </a:rPr>
+              <a:t>modifica</a:t>
+            </a:r>
+            <a:r>
+              <a:rPr lang="es-ES" sz="1600" b="0" i="0" dirty="0">
+                <a:solidFill>
+                  <a:srgbClr val="0A0A0A"/>
+                </a:solidFill>
+                <a:effectLst/>
+                <a:latin typeface="Google Sans"/>
+              </a:rPr>
+              <a:t> o "mapea" los datos antes de que lleguen al destino final</a:t>
+            </a:r>
+            <a:endParaRPr lang="es-ES" sz="1600" dirty="0"/>
+          </a:p>
+          <a:p>
+            <a:r>
+              <a:rPr lang="es-ES" sz="1600" b="1" dirty="0"/>
+              <a:t>[</a:t>
+            </a:r>
+            <a:r>
+              <a:rPr lang="es-ES" sz="1600" b="1" dirty="0" err="1"/>
+              <a:t>frombody</a:t>
+            </a:r>
+            <a:r>
+              <a:rPr lang="es-ES" sz="1600" b="1" dirty="0"/>
+              <a:t>]</a:t>
+            </a:r>
+            <a:r>
+              <a:rPr lang="es-ES" sz="1600" dirty="0"/>
+              <a:t> Se usa en los parámetros de un controlador para decirle a C#: "Busca los datos de este objeto dentro del cuerpo (</a:t>
+            </a:r>
+            <a:r>
+              <a:rPr lang="es-ES" sz="1600" dirty="0" err="1"/>
+              <a:t>body</a:t>
+            </a:r>
+            <a:r>
+              <a:rPr lang="es-ES" sz="1600" dirty="0"/>
+              <a:t>) de la petición HTTP que me enviaron</a:t>
+            </a:r>
+          </a:p>
+          <a:p>
+            <a:endParaRPr lang="es-ES" sz="1600" dirty="0"/>
+          </a:p>
+        </p:txBody>
+      </p:sp>
+    </p:spTree>
+    <p:extLst>
+      <p:ext uri="{BB962C8B-B14F-4D97-AF65-F5344CB8AC3E}">
+        <p14:creationId xmlns:p14="http://schemas.microsoft.com/office/powerpoint/2010/main" val="1884975599"/>
+      </p:ext>
+    </p:extLst>
+  </p:cSld>
+  <p:clrMapOvr>
+    <a:masterClrMapping/>
+  </p:clrMapOvr>
+</p:sld>
+</file>
+
+<file path=ppt/slides/slide22.xml><?xml version="1.0" encoding="utf-8"?>
+<p:sld xmlns:a="http://schemas.openxmlformats.org/drawingml/2006/main" xmlns:r="http://schemas.openxmlformats.org/officeDocument/2006/relationships" xmlns:p="http://schemas.openxmlformats.org/presentationml/2006/main">
+  <p:cSld>
+    <p:spTree>
+      <p:nvGrpSpPr>
+        <p:cNvPr id="1" name=""/>
+        <p:cNvGrpSpPr/>
+        <p:nvPr/>
+      </p:nvGrpSpPr>
+      <p:grpSpPr>
+        <a:xfrm>
+          <a:off x="0" y="0"/>
+          <a:ext cx="0" cy="0"/>
+          <a:chOff x="0" y="0"/>
+          <a:chExt cx="0" cy="0"/>
+        </a:xfrm>
+      </p:grpSpPr>
+      <p:sp>
+        <p:nvSpPr>
+          <p:cNvPr id="5" name="CuadroTexto 4">
+            <a:extLst>
+              <a:ext uri="{FF2B5EF4-FFF2-40B4-BE49-F238E27FC236}">
+                <a16:creationId xmlns:a16="http://schemas.microsoft.com/office/drawing/2014/main" id="{2BC420AA-DF87-4331-AEB4-3E145A370204}"/>
+              </a:ext>
+            </a:extLst>
+          </p:cNvPr>
+          <p:cNvSpPr txBox="1"/>
+          <p:nvPr/>
+        </p:nvSpPr>
+        <p:spPr>
+          <a:xfrm>
+            <a:off x="638980" y="1659285"/>
+            <a:ext cx="10036366" cy="4278094"/>
+          </a:xfrm>
+          <a:prstGeom prst="rect">
+            <a:avLst/>
+          </a:prstGeom>
+          <a:noFill/>
+        </p:spPr>
+        <p:txBody>
+          <a:bodyPr wrap="square">
+            <a:spAutoFit/>
+          </a:bodyPr>
+          <a:lstStyle/>
+          <a:p>
+            <a:r>
+              <a:rPr lang="es-ES" sz="1600" b="1" dirty="0">
+                <a:highlight>
+                  <a:srgbClr val="FFFF00"/>
+                </a:highlight>
+              </a:rPr>
+              <a:t>ESB – Interface</a:t>
+            </a:r>
+          </a:p>
+          <a:p>
+            <a:endParaRPr lang="es-ES" sz="1600" dirty="0"/>
+          </a:p>
+          <a:p>
+            <a:r>
+              <a:rPr lang="es-ES" sz="1600" b="1" dirty="0" err="1"/>
+              <a:t>Task</a:t>
+            </a:r>
+            <a:r>
+              <a:rPr lang="es-ES" sz="1600" b="1" dirty="0"/>
+              <a:t>&lt;T?&gt; </a:t>
+            </a:r>
+            <a:r>
+              <a:rPr lang="es-ES" sz="1600" b="1" dirty="0" err="1"/>
+              <a:t>RouteAndTransformAsync</a:t>
+            </a:r>
+            <a:r>
+              <a:rPr lang="es-ES" sz="1600" b="1" dirty="0"/>
+              <a:t>&lt;T&gt;</a:t>
+            </a:r>
+            <a:r>
+              <a:rPr lang="es-ES" sz="1600" dirty="0"/>
+              <a:t> método que realiza una tarea en segundo plano y devuelve un objeto de tipo genérico</a:t>
+            </a:r>
+          </a:p>
+          <a:p>
+            <a:r>
+              <a:rPr lang="es-ES" sz="1600" b="1" dirty="0" err="1"/>
+              <a:t>Task</a:t>
+            </a:r>
+            <a:r>
+              <a:rPr lang="es-ES" sz="1600" b="1" dirty="0"/>
+              <a:t>&lt;</a:t>
+            </a:r>
+            <a:r>
+              <a:rPr lang="es-ES" sz="1600" b="1" dirty="0" err="1"/>
+              <a:t>HttpResponseMessage</a:t>
+            </a:r>
+            <a:r>
+              <a:rPr lang="es-ES" sz="1600" b="1" dirty="0"/>
+              <a:t>&gt; </a:t>
+            </a:r>
+            <a:r>
+              <a:rPr lang="es-ES" sz="1600" b="1" dirty="0" err="1"/>
+              <a:t>RouteRequestAsync</a:t>
+            </a:r>
+            <a:r>
+              <a:rPr lang="es-ES" sz="1600" dirty="0"/>
+              <a:t> </a:t>
+            </a:r>
+            <a:r>
+              <a:rPr lang="es-ES" sz="1600" b="0" i="0" dirty="0">
+                <a:solidFill>
+                  <a:srgbClr val="0A0A0A"/>
+                </a:solidFill>
+                <a:effectLst/>
+                <a:latin typeface="Google Sans"/>
+              </a:rPr>
+              <a:t> método asíncrono que devuelve la </a:t>
+            </a:r>
+            <a:r>
+              <a:rPr lang="es-ES" sz="1600" b="1" i="0" dirty="0">
+                <a:solidFill>
+                  <a:srgbClr val="0A0A0A"/>
+                </a:solidFill>
+                <a:effectLst/>
+                <a:latin typeface="Google Sans"/>
+              </a:rPr>
+              <a:t>respuesta completa</a:t>
+            </a:r>
+            <a:r>
+              <a:rPr lang="es-ES" sz="1600" b="0" i="0" dirty="0">
+                <a:solidFill>
+                  <a:srgbClr val="0A0A0A"/>
+                </a:solidFill>
+                <a:effectLst/>
+                <a:latin typeface="Google Sans"/>
+              </a:rPr>
+              <a:t> de un servidor (código de estado, encabezados y contenido).</a:t>
+            </a:r>
+            <a:endParaRPr lang="es-ES" sz="1600" dirty="0"/>
+          </a:p>
+          <a:p>
+            <a:endParaRPr lang="es-ES" sz="1600" dirty="0"/>
+          </a:p>
+          <a:p>
+            <a:r>
+              <a:rPr lang="es-ES" sz="1600" b="1" dirty="0">
+                <a:highlight>
+                  <a:srgbClr val="FFFF00"/>
+                </a:highlight>
+              </a:rPr>
+              <a:t>Servicio</a:t>
+            </a:r>
+          </a:p>
+          <a:p>
+            <a:endParaRPr lang="es-ES" sz="1600" b="1" dirty="0"/>
+          </a:p>
+          <a:p>
+            <a:r>
+              <a:rPr lang="es-ES" sz="1600" b="1" dirty="0" err="1"/>
+              <a:t>IHttpClientFactory</a:t>
+            </a:r>
+            <a:r>
+              <a:rPr lang="es-ES" sz="1600" b="1" dirty="0"/>
+              <a:t>:</a:t>
+            </a:r>
+            <a:r>
+              <a:rPr lang="es-ES" sz="1600" dirty="0"/>
+              <a:t> fábrica" que gestiona la creación de clientes HTTP. Es la forma de hacer peticiones a otros sitios web en .NET </a:t>
+            </a:r>
+          </a:p>
+          <a:p>
+            <a:r>
+              <a:rPr lang="es-ES" sz="1600" b="1" dirty="0" err="1"/>
+              <a:t>async</a:t>
+            </a:r>
+            <a:r>
+              <a:rPr lang="es-ES" sz="1600" b="1" dirty="0"/>
+              <a:t> </a:t>
+            </a:r>
+            <a:r>
+              <a:rPr lang="es-ES" sz="1600" b="1" dirty="0" err="1"/>
+              <a:t>Task</a:t>
+            </a:r>
+            <a:r>
+              <a:rPr lang="es-ES" sz="1600" b="1" dirty="0"/>
+              <a:t>&lt;</a:t>
+            </a:r>
+            <a:r>
+              <a:rPr lang="es-ES" sz="1600" b="1" dirty="0" err="1"/>
+              <a:t>HttpResponseMessage</a:t>
+            </a:r>
+            <a:r>
+              <a:rPr lang="es-ES" sz="1600" b="1" dirty="0"/>
+              <a:t>&gt;:</a:t>
+            </a:r>
+            <a:r>
+              <a:rPr lang="es-ES" sz="1600" dirty="0"/>
+              <a:t>  función que entrega una respuesta HTTP en el futuro sin detener el programa mientras la busca</a:t>
+            </a:r>
+          </a:p>
+          <a:p>
+            <a:r>
+              <a:rPr lang="es-ES" sz="1600" b="1" dirty="0" err="1"/>
+              <a:t>Swagger</a:t>
+            </a:r>
+            <a:r>
+              <a:rPr lang="es-ES" sz="1600" b="1" dirty="0"/>
+              <a:t>:</a:t>
+            </a:r>
+            <a:r>
+              <a:rPr lang="es-ES" sz="1600" dirty="0"/>
+              <a:t> </a:t>
+            </a:r>
+            <a:r>
+              <a:rPr lang="es-ES" sz="1600" b="0" i="0" dirty="0">
+                <a:solidFill>
+                  <a:srgbClr val="0A0A0A"/>
+                </a:solidFill>
+                <a:effectLst/>
+                <a:latin typeface="Google Sans"/>
+              </a:rPr>
+              <a:t>herramienta que sube un sitio web para probar </a:t>
+            </a:r>
+            <a:r>
+              <a:rPr lang="es-ES" sz="1600" b="0" i="0" dirty="0" err="1">
+                <a:solidFill>
+                  <a:srgbClr val="0A0A0A"/>
+                </a:solidFill>
+                <a:effectLst/>
+                <a:latin typeface="Google Sans"/>
+              </a:rPr>
+              <a:t>endpoints</a:t>
+            </a:r>
+            <a:r>
+              <a:rPr lang="es-ES" sz="1600" b="0" i="0" dirty="0">
+                <a:solidFill>
+                  <a:srgbClr val="0A0A0A"/>
+                </a:solidFill>
+                <a:effectLst/>
+                <a:latin typeface="Google Sans"/>
+              </a:rPr>
+              <a:t> sin necesidad de usar herramientas externas como </a:t>
+            </a:r>
+            <a:r>
+              <a:rPr lang="es-ES" sz="1600" b="0" i="0" dirty="0" err="1">
+                <a:solidFill>
+                  <a:srgbClr val="0A0A0A"/>
+                </a:solidFill>
+                <a:effectLst/>
+                <a:latin typeface="Google Sans"/>
+              </a:rPr>
+              <a:t>Postman</a:t>
+            </a:r>
+            <a:r>
+              <a:rPr lang="es-ES" sz="1600" b="0" i="0" dirty="0">
+                <a:solidFill>
+                  <a:srgbClr val="0A0A0A"/>
+                </a:solidFill>
+                <a:effectLst/>
+                <a:latin typeface="Google Sans"/>
+              </a:rPr>
+              <a:t>.</a:t>
+            </a:r>
+            <a:endParaRPr lang="es-ES" sz="1600" dirty="0"/>
+          </a:p>
+          <a:p>
+            <a:endParaRPr lang="es-ES" sz="1600" dirty="0"/>
+          </a:p>
+          <a:p>
+            <a:r>
+              <a:rPr lang="es-ES" sz="1600" b="1" dirty="0" err="1"/>
+              <a:t>Builder.Build</a:t>
+            </a:r>
+            <a:r>
+              <a:rPr lang="es-ES" sz="1600" b="1" dirty="0"/>
+              <a:t>()</a:t>
+            </a:r>
+            <a:r>
+              <a:rPr lang="es-ES" sz="1600" dirty="0"/>
+              <a:t> comando final que prepara toda la configuración y crea la aplicación lista para funcionar.</a:t>
+            </a:r>
+          </a:p>
+        </p:txBody>
+      </p:sp>
+      <p:sp>
+        <p:nvSpPr>
+          <p:cNvPr id="6" name="CuadroTexto 5">
+            <a:extLst>
+              <a:ext uri="{FF2B5EF4-FFF2-40B4-BE49-F238E27FC236}">
+                <a16:creationId xmlns:a16="http://schemas.microsoft.com/office/drawing/2014/main" id="{0F220360-C56E-4C21-B577-8DAB35A1BF10}"/>
+              </a:ext>
+            </a:extLst>
+          </p:cNvPr>
+          <p:cNvSpPr txBox="1"/>
+          <p:nvPr/>
+        </p:nvSpPr>
+        <p:spPr>
+          <a:xfrm flipH="1">
+            <a:off x="755066" y="447156"/>
+            <a:ext cx="6383863" cy="646331"/>
+          </a:xfrm>
+          <a:prstGeom prst="rect">
+            <a:avLst/>
+          </a:prstGeom>
+          <a:noFill/>
+        </p:spPr>
+        <p:txBody>
+          <a:bodyPr wrap="square" rtlCol="0">
+            <a:spAutoFit/>
+          </a:bodyPr>
+          <a:lstStyle/>
+          <a:p>
+            <a:r>
+              <a:rPr lang="es-ES" sz="3600" dirty="0"/>
+              <a:t>Glosario proyectos</a:t>
+            </a:r>
+          </a:p>
+        </p:txBody>
+      </p:sp>
+    </p:spTree>
+    <p:extLst>
+      <p:ext uri="{BB962C8B-B14F-4D97-AF65-F5344CB8AC3E}">
+        <p14:creationId xmlns:p14="http://schemas.microsoft.com/office/powerpoint/2010/main" val="3608644513"/>
+      </p:ext>
+    </p:extLst>
+  </p:cSld>
+  <p:clrMapOvr>
+    <a:masterClrMapping/>
   </p:clrMapOvr>
 </p:sld>
 </file>

</xml_diff>